<commit_message>
Add chapter 4 presentation update, PDF export and audio history note
Commits the pending chapter 4 presentation changes with its PDF export
and the history entry about the audio narration. Audio recordings in
presentations/ are ignored by Git and stay local.

Co-Authored-By: Claude Opus 5.5 <noreply@anthropic.com>
</commit_message>
<xml_diff>
--- a/presentations/kapitola_04_normalni_rozdeleni.pptx
+++ b/presentations/kapitola_04_normalni_rozdeleni.pptx
@@ -2504,168 +2504,264 @@
               <a:buChar char="•"/>
             </a:pPr>
             <a:r>
-              <a:rPr lang="cs-CZ" altLang="cs-CZ" sz="1200" b="1" i="0" noProof="0">
+              <a:rPr lang="cs-CZ" altLang="cs-CZ" sz="1200" b="1" i="0" noProof="0" dirty="0">
                 <a:latin typeface="Arial"/>
               </a:rPr>
               <a:t>Standardní skór</a:t>
             </a:r>
             <a:r>
-              <a:rPr lang="cs-CZ" altLang="cs-CZ" sz="1200" b="0" i="0" noProof="0">
-                <a:latin typeface="Arial"/>
-              </a:rPr>
-              <a:t> (standard score) vyjadřuje výsledek na škále s určeným středem a variabilitou. Z-skór je jen jedním z nich; testy používají škály, na kterých se většinou vyhneme záporným a desetinným číslům.</a:t>
-            </a:r>
-            <a:endParaRPr lang="cs-CZ" altLang="cs-CZ" sz="1200" noProof="0"/>
-          </a:p>
-          <a:p>
-            <a:pPr marL="228600" indent="-171450">
-              <a:buChar char="•"/>
-            </a:pPr>
-            <a:r>
-              <a:rPr lang="cs-CZ" altLang="cs-CZ" sz="1200" b="0" i="0" noProof="0">
+              <a:rPr lang="cs-CZ" altLang="cs-CZ" sz="1200" b="0" i="0" noProof="0" dirty="0">
+                <a:latin typeface="Arial"/>
+              </a:rPr>
+              <a:t> (standard </a:t>
+            </a:r>
+            <a:r>
+              <a:rPr lang="cs-CZ" altLang="cs-CZ" sz="1200" b="0" i="0" noProof="0" dirty="0" err="1">
+                <a:latin typeface="Arial"/>
+              </a:rPr>
+              <a:t>score</a:t>
+            </a:r>
+            <a:r>
+              <a:rPr lang="cs-CZ" altLang="cs-CZ" sz="1200" b="0" i="0" noProof="0" dirty="0">
+                <a:latin typeface="Arial"/>
+              </a:rPr>
+              <a:t>) vyjadřuje výsledek na škále s určeným středem a variabilitou. Z-skór je jen jedním z nich; testy používají škály, na kterých se většinou vyhneme záporným a desetinným číslům.</a:t>
+            </a:r>
+            <a:endParaRPr lang="cs-CZ" altLang="cs-CZ" sz="1200" noProof="0" dirty="0"/>
+          </a:p>
+          <a:p>
+            <a:pPr marL="228600" indent="-171450">
+              <a:buChar char="•"/>
+            </a:pPr>
+            <a:r>
+              <a:rPr lang="cs-CZ" altLang="cs-CZ" sz="1200" b="0" i="0" noProof="0" dirty="0">
                 <a:latin typeface="Arial"/>
               </a:rPr>
               <a:t>Převod ze z-skóru je lineární: </a:t>
             </a:r>
             <a:r>
-              <a:rPr lang="cs-CZ" altLang="cs-CZ" sz="1200" b="1" i="0" noProof="0">
+              <a:rPr lang="cs-CZ" altLang="cs-CZ" sz="1200" b="1" i="0" noProof="0" dirty="0">
                 <a:latin typeface="Arial"/>
               </a:rPr>
               <a:t>nový skór = nový průměr + nová směrodatná odchylka × z</a:t>
             </a:r>
             <a:r>
-              <a:rPr lang="cs-CZ" altLang="cs-CZ" sz="1200" b="0" i="0" noProof="0">
+              <a:rPr lang="cs-CZ" altLang="cs-CZ" sz="1200" b="0" i="0" noProof="0" dirty="0">
                 <a:latin typeface="Arial"/>
               </a:rPr>
               <a:t>. </a:t>
             </a:r>
             <a:r>
-              <a:rPr lang="cs-CZ" altLang="cs-CZ" sz="1200" b="1" i="0" noProof="0">
+              <a:rPr lang="cs-CZ" altLang="cs-CZ" sz="1200" b="1" i="0" noProof="0" dirty="0">
                 <a:latin typeface="Arial"/>
               </a:rPr>
               <a:t>T-skór</a:t>
             </a:r>
             <a:r>
-              <a:rPr lang="cs-CZ" altLang="cs-CZ" sz="1200" b="0" i="0" noProof="0">
+              <a:rPr lang="cs-CZ" altLang="cs-CZ" sz="1200" b="0" i="0" noProof="0" dirty="0">
                 <a:latin typeface="Arial"/>
               </a:rPr>
               <a:t> má průměr 50 a směrodatnou odchylku 10, </a:t>
             </a:r>
             <a:r>
-              <a:rPr lang="cs-CZ" altLang="cs-CZ" sz="1200" b="1" i="0" noProof="0">
+              <a:rPr lang="cs-CZ" altLang="cs-CZ" sz="1200" b="1" i="0" noProof="0" dirty="0">
                 <a:latin typeface="Arial"/>
               </a:rPr>
               <a:t>IQ-skór</a:t>
             </a:r>
             <a:r>
-              <a:rPr lang="cs-CZ" altLang="cs-CZ" sz="1200" b="0" i="0" noProof="0">
+              <a:rPr lang="cs-CZ" altLang="cs-CZ" sz="1200" b="0" i="0" noProof="0" dirty="0">
                 <a:latin typeface="Arial"/>
               </a:rPr>
               <a:t> 100 a 15, </a:t>
             </a:r>
             <a:r>
-              <a:rPr lang="cs-CZ" altLang="cs-CZ" sz="1200" b="1" i="0" noProof="0">
-                <a:latin typeface="Arial"/>
-              </a:rPr>
-              <a:t>standardní subtestový skór</a:t>
-            </a:r>
-            <a:r>
-              <a:rPr lang="cs-CZ" altLang="cs-CZ" sz="1200" b="0" i="0" noProof="0">
-                <a:latin typeface="Arial"/>
-              </a:rPr>
-              <a:t> často 10 a 3, například u subtestů Wechslerových škál. V českých materiálech se pro něj objevuje i název vážený skór.</a:t>
-            </a:r>
-            <a:endParaRPr lang="cs-CZ" altLang="cs-CZ" sz="1200" noProof="0"/>
-          </a:p>
-          <a:p>
-            <a:pPr marL="228600" indent="-171450">
-              <a:buChar char="•"/>
-            </a:pPr>
-            <a:r>
-              <a:rPr lang="cs-CZ" altLang="cs-CZ" sz="1200" b="0" i="0" noProof="0">
-                <a:latin typeface="Arial"/>
-              </a:rPr>
-              <a:t>Pro z = 1,5 dostaneme T = 50 + 10 × 1,5 = 65, IQ-skór 122,5 a subtestový skór 14,5. Převody lze obrátit: T-skór 65 má z = (65 − 50) / 10 = 1,5.</a:t>
-            </a:r>
-            <a:endParaRPr lang="cs-CZ" altLang="cs-CZ" sz="1200" noProof="0"/>
-          </a:p>
-          <a:p>
-            <a:pPr marL="228600" indent="-171450">
-              <a:buChar char="•"/>
-            </a:pPr>
-            <a:r>
-              <a:rPr lang="cs-CZ" altLang="cs-CZ" sz="1200" b="0" i="1" noProof="0">
+              <a:rPr lang="cs-CZ" altLang="cs-CZ" sz="1200" b="1" i="0" noProof="0" dirty="0">
+                <a:latin typeface="Arial"/>
+              </a:rPr>
+              <a:t>standardní </a:t>
+            </a:r>
+            <a:r>
+              <a:rPr lang="cs-CZ" altLang="cs-CZ" sz="1200" b="1" i="0" noProof="0" dirty="0" err="1">
+                <a:latin typeface="Arial"/>
+              </a:rPr>
+              <a:t>subtestový</a:t>
+            </a:r>
+            <a:r>
+              <a:rPr lang="cs-CZ" altLang="cs-CZ" sz="1200" b="1" i="0" noProof="0" dirty="0">
+                <a:latin typeface="Arial"/>
+              </a:rPr>
+              <a:t> skór</a:t>
+            </a:r>
+            <a:r>
+              <a:rPr lang="cs-CZ" altLang="cs-CZ" sz="1200" b="0" i="0" noProof="0" dirty="0">
+                <a:latin typeface="Arial"/>
+              </a:rPr>
+              <a:t> často 10 a 3, například u </a:t>
+            </a:r>
+            <a:r>
+              <a:rPr lang="cs-CZ" altLang="cs-CZ" sz="1200" b="0" i="0" noProof="0" dirty="0" err="1">
+                <a:latin typeface="Arial"/>
+              </a:rPr>
+              <a:t>subtestů</a:t>
+            </a:r>
+            <a:r>
+              <a:rPr lang="cs-CZ" altLang="cs-CZ" sz="1200" b="0" i="0" noProof="0" dirty="0">
+                <a:latin typeface="Arial"/>
+              </a:rPr>
+              <a:t> </a:t>
+            </a:r>
+            <a:r>
+              <a:rPr lang="cs-CZ" altLang="cs-CZ" sz="1200" b="0" i="0" noProof="0" dirty="0" err="1">
+                <a:latin typeface="Arial"/>
+              </a:rPr>
+              <a:t>Wechslerových</a:t>
+            </a:r>
+            <a:r>
+              <a:rPr lang="cs-CZ" altLang="cs-CZ" sz="1200" b="0" i="0" noProof="0" dirty="0">
+                <a:latin typeface="Arial"/>
+              </a:rPr>
+              <a:t> škál. V českých materiálech se pro něj objevuje i název vážený skór.</a:t>
+            </a:r>
+            <a:endParaRPr lang="cs-CZ" altLang="cs-CZ" sz="1200" noProof="0" dirty="0"/>
+          </a:p>
+          <a:p>
+            <a:pPr marL="228600" indent="-171450">
+              <a:buChar char="•"/>
+            </a:pPr>
+            <a:r>
+              <a:rPr lang="cs-CZ" altLang="cs-CZ" sz="1200" b="0" i="0" noProof="0" dirty="0">
+                <a:latin typeface="Arial"/>
+              </a:rPr>
+              <a:t>Pro z = 1,5 dostaneme T = 50 + 10 × 1,5 = 65, IQ-skór 122,5 a </a:t>
+            </a:r>
+            <a:r>
+              <a:rPr lang="cs-CZ" altLang="cs-CZ" sz="1200" b="0" i="0" noProof="0" dirty="0" err="1">
+                <a:latin typeface="Arial"/>
+              </a:rPr>
+              <a:t>subtestový</a:t>
+            </a:r>
+            <a:r>
+              <a:rPr lang="cs-CZ" altLang="cs-CZ" sz="1200" b="0" i="0" noProof="0" dirty="0">
+                <a:latin typeface="Arial"/>
+              </a:rPr>
+              <a:t> skór 14,5. Převody lze obrátit: T-skór 65 má z = (65 − 50) / 10 = 1,5.</a:t>
+            </a:r>
+            <a:endParaRPr lang="cs-CZ" altLang="cs-CZ" sz="1200" noProof="0" dirty="0"/>
+          </a:p>
+          <a:p>
+            <a:pPr marL="228600" indent="-171450">
+              <a:buChar char="•"/>
+            </a:pPr>
+            <a:r>
+              <a:rPr lang="cs-CZ" altLang="cs-CZ" sz="1200" b="0" i="1" noProof="0" dirty="0">
                 <a:latin typeface="Arial"/>
               </a:rPr>
               <a:t>Převod na škálu IQ nemění, co test měří</a:t>
             </a:r>
             <a:r>
-              <a:rPr lang="cs-CZ" altLang="cs-CZ" sz="1200" b="0" i="0" noProof="0">
+              <a:rPr lang="cs-CZ" altLang="cs-CZ" sz="1200" b="0" i="0" noProof="0" dirty="0">
                 <a:latin typeface="Arial"/>
               </a:rPr>
               <a:t>: u testu pozornosti píšeme „výsledek vyjádřený na škále IQ-skórů“, ne „inteligence 122,5“.</a:t>
             </a:r>
-            <a:endParaRPr lang="cs-CZ" altLang="cs-CZ" sz="1200" noProof="0"/>
-          </a:p>
-          <a:p>
-            <a:pPr marL="228600" indent="-171450">
-              <a:buChar char="•"/>
-            </a:pPr>
-            <a:r>
-              <a:rPr lang="cs-CZ" altLang="cs-CZ" sz="1200" b="1" i="0" noProof="0">
+            <a:endParaRPr lang="cs-CZ" altLang="cs-CZ" sz="1200" noProof="0" dirty="0"/>
+          </a:p>
+          <a:p>
+            <a:pPr marL="228600" indent="-171450">
+              <a:buChar char="•"/>
+            </a:pPr>
+            <a:r>
+              <a:rPr lang="cs-CZ" altLang="cs-CZ" sz="1200" b="1" i="0" noProof="0" dirty="0">
                 <a:latin typeface="Arial"/>
               </a:rPr>
               <a:t>K samotnému lineárnímu převodu normální rozdělení nepotřebujeme.</a:t>
             </a:r>
             <a:r>
-              <a:rPr lang="cs-CZ" altLang="cs-CZ" sz="1200" b="0" i="0" noProof="0">
+              <a:rPr lang="cs-CZ" altLang="cs-CZ" sz="1200" b="0" i="0" noProof="0" dirty="0">
                 <a:latin typeface="Arial"/>
               </a:rPr>
               <a:t> Teprve přiřazení percentilového pořadí pomocí normální křivky vyžaduje normální model. Poslední řada obrázku to ukazuje: z-skór z 0 na 1 zvýší modelové percentilové pořadí asi o 34,1 bodu, z 1 na 2 jen o 13,6. Percentilové pořadí nemá rovnoměrné rozestupy.</a:t>
             </a:r>
-            <a:endParaRPr lang="cs-CZ" altLang="cs-CZ" sz="1200" noProof="0"/>
-          </a:p>
-          <a:p>
-            <a:pPr marL="228600" indent="-171450">
-              <a:buChar char="•"/>
-            </a:pPr>
-            <a:r>
-              <a:rPr lang="cs-CZ" altLang="cs-CZ" sz="1200" b="1" i="0" noProof="0">
+            <a:endParaRPr lang="cs-CZ" altLang="cs-CZ" sz="1200" noProof="0" dirty="0"/>
+          </a:p>
+          <a:p>
+            <a:pPr marL="228600" indent="-171450">
+              <a:buChar char="•"/>
+            </a:pPr>
+            <a:r>
+              <a:rPr lang="cs-CZ" altLang="cs-CZ" sz="1200" b="1" i="0" noProof="0" dirty="0">
                 <a:latin typeface="Arial"/>
               </a:rPr>
               <a:t>Otázka k zamyšlení:</a:t>
             </a:r>
             <a:r>
-              <a:rPr lang="cs-CZ" altLang="cs-CZ" sz="1200" b="0" i="0" noProof="0">
+              <a:rPr lang="cs-CZ" altLang="cs-CZ" sz="1200" b="0" i="0" noProof="0" dirty="0">
                 <a:latin typeface="Arial"/>
               </a:rPr>
               <a:t> Jaký T-skór odpovídá IQ-skóru 85? z = (85 − 100) / 15 = −1, tedy T = 40.</a:t>
             </a:r>
-            <a:endParaRPr lang="cs-CZ" altLang="cs-CZ" sz="1200" noProof="0"/>
-          </a:p>
-          <a:p>
-            <a:pPr marL="228600" indent="-171450">
-              <a:buChar char="•"/>
-            </a:pPr>
-            <a:r>
-              <a:rPr lang="cs-CZ" altLang="cs-CZ" sz="1200" b="0" i="0" noProof="0">
+            <a:endParaRPr lang="cs-CZ" altLang="cs-CZ" sz="1200" noProof="0" dirty="0"/>
+          </a:p>
+          <a:p>
+            <a:pPr marL="228600" indent="-171450">
+              <a:buChar char="•"/>
+            </a:pPr>
+            <a:r>
+              <a:rPr lang="cs-CZ" altLang="cs-CZ" sz="1200" b="0" i="0" noProof="0" dirty="0">
                 <a:latin typeface="Arial"/>
               </a:rPr>
               <a:t>Čas pro vyučujícího: přibližně 2 min.</a:t>
             </a:r>
-            <a:endParaRPr lang="cs-CZ" altLang="cs-CZ" sz="1200" noProof="0"/>
-          </a:p>
-          <a:p>
-            <a:pPr marL="228600" indent="-171450">
-              <a:buChar char="•"/>
-            </a:pPr>
-            <a:r>
-              <a:rPr lang="cs-CZ" altLang="cs-CZ" sz="1200" b="0" i="0" noProof="0">
-                <a:latin typeface="Arial"/>
-              </a:rPr>
-              <a:t>Podklad: kapitola 4, Normální rozdělení a standardní skóry, příslušný oddíl: https://reckak.github.io/statistics-for-psychology/quarto/kapitola_04.html#sec-prepocty-skoru. Příklady jsou modelové výukové údaje nebo simulace.</a:t>
-            </a:r>
-            <a:endParaRPr lang="cs-CZ" altLang="cs-CZ" sz="1200" noProof="0"/>
+            <a:endParaRPr lang="cs-CZ" altLang="cs-CZ" sz="1200" noProof="0" dirty="0"/>
+          </a:p>
+          <a:p>
+            <a:pPr marL="228600" indent="-171450">
+              <a:buChar char="•"/>
+            </a:pPr>
+            <a:r>
+              <a:rPr lang="cs-CZ" altLang="cs-CZ" sz="1200" b="0" i="0" noProof="0" dirty="0">
+                <a:latin typeface="Arial"/>
+              </a:rPr>
+              <a:t>Podklad: kapitola 4, Normální rozdělení a standardní skóry, příslušný oddíl: https://reckak.github.io/</a:t>
+            </a:r>
+            <a:r>
+              <a:rPr lang="cs-CZ" altLang="cs-CZ" sz="1200" b="0" i="0" noProof="0" dirty="0" err="1">
+                <a:latin typeface="Arial"/>
+              </a:rPr>
+              <a:t>statistics</a:t>
+            </a:r>
+            <a:r>
+              <a:rPr lang="cs-CZ" altLang="cs-CZ" sz="1200" b="0" i="0" noProof="0" dirty="0">
+                <a:latin typeface="Arial"/>
+              </a:rPr>
+              <a:t>-</a:t>
+            </a:r>
+            <a:r>
+              <a:rPr lang="cs-CZ" altLang="cs-CZ" sz="1200" b="0" i="0" noProof="0" dirty="0" err="1">
+                <a:latin typeface="Arial"/>
+              </a:rPr>
+              <a:t>for</a:t>
+            </a:r>
+            <a:r>
+              <a:rPr lang="cs-CZ" altLang="cs-CZ" sz="1200" b="0" i="0" noProof="0" dirty="0">
+                <a:latin typeface="Arial"/>
+              </a:rPr>
+              <a:t>-psychology/</a:t>
+            </a:r>
+            <a:r>
+              <a:rPr lang="cs-CZ" altLang="cs-CZ" sz="1200" b="0" i="0" noProof="0" dirty="0" err="1">
+                <a:latin typeface="Arial"/>
+              </a:rPr>
+              <a:t>quarto</a:t>
+            </a:r>
+            <a:r>
+              <a:rPr lang="cs-CZ" altLang="cs-CZ" sz="1200" b="0" i="0" noProof="0" dirty="0">
+                <a:latin typeface="Arial"/>
+              </a:rPr>
+              <a:t>/kapitola_04.html#sec-prepocty-skoru. Příklady jsou modelové výukové údaje nebo simulace.</a:t>
+            </a:r>
+            <a:endParaRPr lang="cs-CZ" altLang="cs-CZ" sz="1200" noProof="0" dirty="0"/>
           </a:p>
         </p:txBody>
       </p:sp>
@@ -13859,7 +13955,7 @@
           <a:p>
             <a:pPr algn="l"/>
             <a:r>
-              <a:rPr lang="cs-CZ" altLang="cs-CZ" sz="2325" b="0" noProof="0">
+              <a:rPr lang="cs-CZ" altLang="cs-CZ" sz="2325" b="0" noProof="0" dirty="0">
                 <a:solidFill>
                   <a:srgbClr val="142A3B"/>
                 </a:solidFill>
@@ -13870,7 +13966,7 @@
               <a:t>Nový skór = nový průměr + nová SD × </a:t>
             </a:r>
             <a:r>
-              <a:rPr lang="cs-CZ" altLang="cs-CZ" sz="2325" b="0" i="1" noProof="0">
+              <a:rPr lang="cs-CZ" altLang="cs-CZ" sz="2325" b="0" i="1" noProof="0" dirty="0">
                 <a:solidFill>
                   <a:srgbClr val="142A3B"/>
                 </a:solidFill>
@@ -13880,7 +13976,7 @@
               </a:rPr>
               <a:t>z</a:t>
             </a:r>
-            <a:endParaRPr lang="cs-CZ" altLang="cs-CZ" sz="2325" noProof="0"/>
+            <a:endParaRPr lang="cs-CZ" altLang="cs-CZ" sz="2325" noProof="0" dirty="0"/>
           </a:p>
         </p:txBody>
       </p:sp>
@@ -13893,7 +13989,7 @@
           <p:nvPr>
             <p:extLst>
               <p:ext uri="{D42A27DB-BD31-4B8C-83A1-F6EECF244321}">
-                <p14:modId xmlns:p14="http://schemas.microsoft.com/office/powerpoint/2010/main" val="3247685530"/>
+                <p14:modId xmlns:p14="http://schemas.microsoft.com/office/powerpoint/2010/main" val="3723666800"/>
               </p:ext>
             </p:extLst>
           </p:nvPr>
@@ -14036,7 +14132,7 @@
                     <a:p>
                       <a:pPr algn="l"/>
                       <a:r>
-                        <a:rPr lang="cs-CZ" altLang="cs-CZ" sz="1875" b="1" noProof="0">
+                        <a:rPr lang="cs-CZ" altLang="cs-CZ" sz="1875" b="1" noProof="0" dirty="0">
                           <a:solidFill>
                             <a:srgbClr val="FFFFFF"/>
                           </a:solidFill>
@@ -14046,7 +14142,7 @@
                         </a:rPr>
                         <a:t>SD</a:t>
                       </a:r>
-                      <a:endParaRPr lang="cs-CZ" altLang="cs-CZ" sz="1875" noProof="0"/>
+                      <a:endParaRPr lang="cs-CZ" altLang="cs-CZ" sz="1875" noProof="0" dirty="0"/>
                     </a:p>
                   </a:txBody>
                   <a:tcPr marL="152400" marR="114300" marT="57150" marB="57150" anchor="ctr">
@@ -14227,7 +14323,7 @@
                     <a:p>
                       <a:pPr algn="l"/>
                       <a:r>
-                        <a:rPr lang="cs-CZ" altLang="cs-CZ" sz="1875" b="0" noProof="0">
+                        <a:rPr lang="cs-CZ" altLang="cs-CZ" sz="1875" b="0" noProof="0" dirty="0">
                           <a:solidFill>
                             <a:srgbClr val="142A3B"/>
                           </a:solidFill>
@@ -14237,7 +14333,7 @@
                         </a:rPr>
                         <a:t>1</a:t>
                       </a:r>
-                      <a:endParaRPr lang="cs-CZ" altLang="cs-CZ" sz="1875" noProof="0"/>
+                      <a:endParaRPr lang="cs-CZ" altLang="cs-CZ" sz="1875" noProof="0" dirty="0"/>
                     </a:p>
                   </a:txBody>
                   <a:tcPr marL="152400" marR="114300" marT="57150" marB="57150" anchor="ctr">
@@ -14919,7 +15015,7 @@
           <a:p>
             <a:pPr algn="l"/>
             <a:r>
-              <a:rPr lang="cs-CZ" altLang="cs-CZ" sz="2325" b="0" noProof="0">
+              <a:rPr lang="cs-CZ" altLang="cs-CZ" sz="2325" b="0" noProof="0" dirty="0">
                 <a:solidFill>
                   <a:srgbClr val="142A3B"/>
                 </a:solidFill>
@@ -14929,7 +15025,7 @@
               </a:rPr>
               <a:t>Lineární převod normalitu nepotřebuje; percentilové pořadí ano</a:t>
             </a:r>
-            <a:endParaRPr lang="cs-CZ" altLang="cs-CZ" sz="2325" noProof="0"/>
+            <a:endParaRPr lang="cs-CZ" altLang="cs-CZ" sz="2325" noProof="0" dirty="0"/>
           </a:p>
         </p:txBody>
       </p:sp>

</xml_diff>

<commit_message>
Sladit prezentaci kapitoly 4 s novou simulací těžších chvostů
Snímek 30 má nový obrázek (původní styl, nová data) a v poznámkách
exces 3,23 a nové percentily. DOCX poznámek upraven jen v týchž
větách, PDF znovu exportováno z PowerPointu. Nahrávka kapitoly 4
zůstává s původními čísly.

Co-Authored-By: Claude Opus 5.5 <noreply@anthropic.com>
</commit_message>
<xml_diff>
--- a/presentations/kapitola_04_normalni_rozdeleni.pptx
+++ b/presentations/kapitola_04_normalni_rozdeleni.pptx
@@ -4566,7 +4566,7 @@
               <a:rPr lang="cs-CZ" altLang="cs-CZ" sz="1200" b="0" i="0" noProof="0">
                 <a:latin typeface="Arial"/>
               </a:rPr>
-              <a:t> a kladným excesem (zde 5,01) nazýváme </a:t>
+              <a:t> a kladným excesem (zde 3,23) nazýváme </a:t>
             </a:r>
             <a:r>
               <a:rPr lang="cs-CZ" altLang="cs-CZ" sz="1200" b="1" i="0" noProof="0">
@@ -4590,7 +4590,7 @@
               <a:rPr lang="cs-CZ" altLang="cs-CZ" sz="1200" b="0" i="0" noProof="0">
                 <a:latin typeface="Arial"/>
               </a:rPr>
-              <a:t>Model by podcenil krajní výsledky: 99. percentil 79,9 bodu místo 88,6. Kvartily by naopak umístil dál od středu (39,5 a 57,6 místo 42,1 a 55,1), protože většina hodnot leží blíž středu.</a:t>
+              <a:t>Model by na obou koncích podcenil krajní výsledky: 1. percentil 22,0 bodu místo 15,1 a 99. percentil 79,9 bodu místo 87,8. Kvartily by naopak umístil dál od středu (42,5 a 59,3 místo 45,4 a 56,6), protože většina hodnot leží blíž středu.</a:t>
             </a:r>
             <a:endParaRPr lang="cs-CZ" altLang="cs-CZ" sz="1200" noProof="0"/>
           </a:p>

</xml_diff>